<commit_message>
feat(design): enforce C-level slide and deliverable design standards across agent runtime
</commit_message>
<xml_diff>
--- a/src/workspaces/protein-bar/Protein_Bar_Week_3_Checklist.pptx
+++ b/src/workspaces/protein-bar/Protein_Bar_Week_3_Checklist.pptx
@@ -8,10 +8,6 @@
     <p:sldId id="256" r:id="rId7"/>
     <p:sldId id="257" r:id="rId8"/>
     <p:sldId id="258" r:id="rId9"/>
-    <p:sldId id="259" r:id="rId10"/>
-    <p:sldId id="260" r:id="rId11"/>
-    <p:sldId id="261" r:id="rId12"/>
-    <p:sldId id="262" r:id="rId13"/>
   </p:sldIdLst>
   <p:sldSz cx="12191695" cy="6858000" type="screen4x3"/>
   <p:notesSz cx="6858000" cy="9144000"/>
@@ -3087,6 +3083,14 @@
 <file path=ppt/slides/slide1.xml><?xml version="1.0" encoding="utf-8"?>
 <p:sld xmlns:a="http://schemas.openxmlformats.org/drawingml/2006/main" xmlns:p="http://schemas.openxmlformats.org/presentationml/2006/main" xmlns:r="http://schemas.openxmlformats.org/officeDocument/2006/relationships">
   <p:cSld>
+    <p:bg>
+      <p:bgPr>
+        <a:solidFill>
+          <a:srgbClr val="0B132B"/>
+        </a:solidFill>
+        <a:effectLst/>
+      </p:bgPr>
+    </p:bg>
     <p:spTree>
       <p:nvGrpSpPr>
         <p:cNvPr id="1" name=""/>
@@ -3096,23 +3100,99 @@
       <p:grpSpPr/>
       <p:sp>
         <p:nvSpPr>
-          <p:cNvPr id="2" name="Rectangle 1"/>
-          <p:cNvSpPr/>
+          <p:cNvPr id="2" name="TextBox 1"/>
+          <p:cNvSpPr txBox="1"/>
           <p:nvPr/>
         </p:nvSpPr>
         <p:spPr>
           <a:xfrm>
-            <a:off x="0" y="0"/>
-            <a:ext cx="12191695" cy="6858000"/>
+            <a:off x="914400" y="1645920"/>
+            <a:ext cx="10332720" cy="365760"/>
           </a:xfrm>
           <a:prstGeom prst="rect">
             <a:avLst/>
           </a:prstGeom>
+          <a:noFill/>
+        </p:spPr>
+        <p:txBody>
+          <a:bodyPr wrap="none">
+            <a:spAutoFit/>
+          </a:bodyPr>
+          <a:lstStyle/>
+          <a:p>
+            <a:pPr>
+              <a:defRPr sz="1200" b="1">
+                <a:solidFill>
+                  <a:srgbClr val="48CAE4"/>
+                </a:solidFill>
+              </a:defRPr>
+            </a:pPr>
+            <a:r>
+              <a:t>EXECUTIVE OPERATIONAL CHECKLIST</a:t>
+            </a:r>
+          </a:p>
+        </p:txBody>
+      </p:sp>
+      <p:sp>
+        <p:nvSpPr>
+          <p:cNvPr id="3" name="TextBox 2"/>
+          <p:cNvSpPr txBox="1"/>
+          <p:nvPr/>
+        </p:nvSpPr>
+        <p:spPr>
+          <a:xfrm>
+            <a:off x="914400" y="2103120"/>
+            <a:ext cx="10332720" cy="1828800"/>
+          </a:xfrm>
+          <a:prstGeom prst="rect">
+            <a:avLst/>
+          </a:prstGeom>
+          <a:noFill/>
+        </p:spPr>
+        <p:txBody>
+          <a:bodyPr wrap="none">
+            <a:spAutoFit/>
+          </a:bodyPr>
+          <a:lstStyle/>
+          <a:p>
+            <a:pPr>
+              <a:defRPr sz="3600" b="1">
+                <a:solidFill>
+                  <a:srgbClr val="FFFFFF"/>
+                </a:solidFill>
+              </a:defRPr>
+            </a:pPr>
+            <a:r>
+              <a:t>Kế Hoạch Triển Khai Tuần 3</a:t>
+            </a:r>
+            <a:br/>
+            <a:r>
+              <a:t>(24/08 – 30/08/2026)</a:t>
+            </a:r>
+          </a:p>
+        </p:txBody>
+      </p:sp>
+      <p:sp>
+        <p:nvSpPr>
+          <p:cNvPr id="4" name="Rounded Rectangle 3"/>
+          <p:cNvSpPr/>
+          <p:nvPr/>
+        </p:nvSpPr>
+        <p:spPr>
+          <a:xfrm>
+            <a:off x="914400" y="4389120"/>
+            <a:ext cx="10360152" cy="1463040"/>
+          </a:xfrm>
+          <a:prstGeom prst="roundRect">
+            <a:avLst/>
+          </a:prstGeom>
           <a:solidFill>
-            <a:srgbClr val="12372A"/>
+            <a:srgbClr val="1C2541"/>
           </a:solidFill>
-          <a:ln>
-            <a:noFill/>
+          <a:ln w="12700">
+            <a:solidFill>
+              <a:srgbClr val="3A506B"/>
+            </a:solidFill>
           </a:ln>
         </p:spPr>
         <p:style>
@@ -3139,14 +3219,14 @@
       </p:sp>
       <p:sp>
         <p:nvSpPr>
-          <p:cNvPr id="3" name="TextBox 2"/>
+          <p:cNvPr id="5" name="TextBox 4"/>
           <p:cNvSpPr txBox="1"/>
           <p:nvPr/>
         </p:nvSpPr>
         <p:spPr>
           <a:xfrm>
-            <a:off x="640080" y="502920"/>
-            <a:ext cx="10881360" cy="685800"/>
+            <a:off x="1143000" y="4572000"/>
+            <a:ext cx="9902952" cy="1097280"/>
           </a:xfrm>
           <a:prstGeom prst="rect">
             <a:avLst/>
@@ -3160,29 +3240,71 @@
           <a:lstStyle/>
           <a:p>
             <a:pPr>
-              <a:defRPr sz="2800" b="1">
+              <a:defRPr sz="1500" b="1">
+                <a:solidFill>
+                  <a:srgbClr val="06D6A0"/>
+                </a:solidFill>
+                <a:latin typeface="Segoe UI"/>
+              </a:defRPr>
+            </a:pPr>
+            <a:r>
+              <a:t>Mục Tiêu Trọng Tâm Tuần 3</a:t>
+            </a:r>
+          </a:p>
+          <a:p>
+            <a:pPr>
+              <a:spcBef>
+                <a:spcPts val="600"/>
+              </a:spcBef>
+              <a:defRPr sz="1150">
                 <a:solidFill>
                   <a:srgbClr val="FFFFFF"/>
                 </a:solidFill>
-                <a:latin typeface="Aptos"/>
+                <a:latin typeface="Segoe UI"/>
               </a:defRPr>
             </a:pPr>
             <a:r>
-              <a:t>Protein Bar Thảo Điền</a:t>
-            </a:r>
-          </a:p>
-        </p:txBody>
-      </p:sp>
-      <p:sp>
-        <p:nvSpPr>
-          <p:cNvPr id="4" name="TextBox 3"/>
+              <a:t>Chốt địa điểm mặt bằng Thảo Điền (kiểm tra ngập nước) • Hoàn thiện hồ sơ ĐKKD • Tasting 5 SKU RTD đầu tiên • Khóa dự toán COGS menu.</a:t>
+            </a:r>
+          </a:p>
+        </p:txBody>
+      </p:sp>
+    </p:spTree>
+  </p:cSld>
+  <p:clrMapOvr>
+    <a:masterClrMapping/>
+  </p:clrMapOvr>
+</p:sld>
+</file>
+
+<file path=ppt/slides/slide2.xml><?xml version="1.0" encoding="utf-8"?>
+<p:sld xmlns:a="http://schemas.openxmlformats.org/drawingml/2006/main" xmlns:p="http://schemas.openxmlformats.org/presentationml/2006/main" xmlns:r="http://schemas.openxmlformats.org/officeDocument/2006/relationships">
+  <p:cSld>
+    <p:bg>
+      <p:bgPr>
+        <a:solidFill>
+          <a:srgbClr val="0B132B"/>
+        </a:solidFill>
+        <a:effectLst/>
+      </p:bgPr>
+    </p:bg>
+    <p:spTree>
+      <p:nvGrpSpPr>
+        <p:cNvPr id="1" name=""/>
+        <p:cNvGrpSpPr/>
+        <p:nvPr/>
+      </p:nvGrpSpPr>
+      <p:grpSpPr/>
+      <p:sp>
+        <p:nvSpPr>
+          <p:cNvPr id="2" name="TextBox 1"/>
           <p:cNvSpPr txBox="1"/>
           <p:nvPr/>
         </p:nvSpPr>
         <p:spPr>
           <a:xfrm>
-            <a:off x="685800" y="2057400"/>
-            <a:ext cx="10789920" cy="1371600"/>
+            <a:off x="731520" y="365760"/>
+            <a:ext cx="10698480" cy="320040"/>
           </a:xfrm>
           <a:prstGeom prst="rect">
             <a:avLst/>
@@ -3190,48 +3312,82 @@
           <a:noFill/>
         </p:spPr>
         <p:txBody>
-          <a:bodyPr wrap="square">
+          <a:bodyPr wrap="none">
             <a:spAutoFit/>
           </a:bodyPr>
           <a:lstStyle/>
           <a:p>
             <a:pPr>
-              <a:defRPr sz="2200" b="0">
-                <a:solidFill>
-                  <a:srgbClr val="FFFFFF"/>
-                </a:solidFill>
-                <a:latin typeface="Aptos"/>
+              <a:defRPr sz="1100" b="1">
+                <a:solidFill>
+                  <a:srgbClr val="48CAE4"/>
+                </a:solidFill>
+                <a:latin typeface="Segoe UI"/>
               </a:defRPr>
             </a:pPr>
             <a:r>
-              <a:t>Checklist vận hành tuần 3 · 24–30/08/2026</a:t>
-            </a:r>
-            <a:br/>
-            <a:r>
-              <a:t>Mục tiêu: chốt shortlist mặt bằng và xác thực sản phẩm</a:t>
-            </a:r>
-          </a:p>
-        </p:txBody>
-      </p:sp>
-      <p:sp>
-        <p:nvSpPr>
-          <p:cNvPr id="5" name="Rectangle 4"/>
-          <p:cNvSpPr/>
+              <a:t>PROTEIN BAR THẢO ĐIỀN — WEEK 3 OPERATIONS</a:t>
+            </a:r>
+          </a:p>
+        </p:txBody>
+      </p:sp>
+      <p:sp>
+        <p:nvSpPr>
+          <p:cNvPr id="3" name="TextBox 2"/>
+          <p:cNvSpPr txBox="1"/>
           <p:nvPr/>
         </p:nvSpPr>
         <p:spPr>
           <a:xfrm>
-            <a:off x="685800" y="5074920"/>
-            <a:ext cx="1828800" cy="73152"/>
+            <a:off x="731520" y="640080"/>
+            <a:ext cx="10698480" cy="731520"/>
           </a:xfrm>
           <a:prstGeom prst="rect">
             <a:avLst/>
           </a:prstGeom>
+          <a:noFill/>
+        </p:spPr>
+        <p:txBody>
+          <a:bodyPr wrap="none">
+            <a:spAutoFit/>
+          </a:bodyPr>
+          <a:lstStyle/>
+          <a:p>
+            <a:pPr>
+              <a:defRPr sz="2200" b="1">
+                <a:solidFill>
+                  <a:srgbClr val="FFFFFF"/>
+                </a:solidFill>
+                <a:latin typeface="Segoe UI"/>
+              </a:defRPr>
+            </a:pPr>
+            <a:r>
+              <a:t>Chỉ Số Cốt Lõi &amp; Khung Thời Gian Mở Quán</a:t>
+            </a:r>
+          </a:p>
+        </p:txBody>
+      </p:sp>
+      <p:sp>
+        <p:nvSpPr>
+          <p:cNvPr id="4" name="Rounded Rectangle 3"/>
+          <p:cNvSpPr/>
+          <p:nvPr/>
+        </p:nvSpPr>
+        <p:spPr>
+          <a:xfrm>
+            <a:off x="731520" y="1645920"/>
+            <a:ext cx="2514600" cy="4572000"/>
+          </a:xfrm>
+          <a:prstGeom prst="roundRect">
+            <a:avLst/>
+          </a:prstGeom>
           <a:solidFill>
-            <a:srgbClr val="E6B566"/>
+            <a:srgbClr val="1C2541"/>
           </a:solidFill>
-          <a:ln>
-            <a:noFill/>
+          <a:ln w="12700">
+            <a:solidFill>
+              <a:srgbClr val="3A506B"/>
+            </a:solidFill>
           </a:ln>
         </p:spPr>
         <p:style>
@@ -3258,14 +3414,14 @@
       </p:sp>
       <p:sp>
         <p:nvSpPr>
-          <p:cNvPr id="6" name="TextBox 5"/>
+          <p:cNvPr id="5" name="TextBox 4"/>
           <p:cNvSpPr txBox="1"/>
           <p:nvPr/>
         </p:nvSpPr>
         <p:spPr>
           <a:xfrm>
-            <a:off x="640080" y="6473952"/>
-            <a:ext cx="10881360" cy="201168"/>
+            <a:off x="960120" y="1828800"/>
+            <a:ext cx="2057400" cy="4206240"/>
           </a:xfrm>
           <a:prstGeom prst="rect">
             <a:avLst/>
@@ -3279,56 +3435,72 @@
           <a:lstStyle/>
           <a:p>
             <a:pPr>
-              <a:defRPr sz="900" b="0">
+              <a:defRPr sz="3200" b="1">
+                <a:solidFill>
+                  <a:srgbClr val="48CAE4"/>
+                </a:solidFill>
+                <a:latin typeface="Segoe UI"/>
+              </a:defRPr>
+            </a:pPr>
+            <a:r>
+              <a:t>05/12</a:t>
+            </a:r>
+          </a:p>
+          <a:p>
+            <a:pPr>
+              <a:spcBef>
+                <a:spcPts val="400"/>
+              </a:spcBef>
+              <a:defRPr sz="1400" b="1">
                 <a:solidFill>
                   <a:srgbClr val="FFFFFF"/>
                 </a:solidFill>
-                <a:latin typeface="Aptos"/>
+                <a:latin typeface="Segoe UI"/>
               </a:defRPr>
             </a:pPr>
             <a:r>
-              <a:t>Protein Bar · Weekly execution brief</a:t>
-            </a:r>
-          </a:p>
-        </p:txBody>
-      </p:sp>
-    </p:spTree>
-  </p:cSld>
-  <p:clrMapOvr>
-    <a:masterClrMapping/>
-  </p:clrMapOvr>
-</p:sld>
-</file>
-
-<file path=ppt/slides/slide2.xml><?xml version="1.0" encoding="utf-8"?>
-<p:sld xmlns:a="http://schemas.openxmlformats.org/drawingml/2006/main" xmlns:p="http://schemas.openxmlformats.org/presentationml/2006/main" xmlns:r="http://schemas.openxmlformats.org/officeDocument/2006/relationships">
-  <p:cSld>
-    <p:spTree>
-      <p:nvGrpSpPr>
-        <p:cNvPr id="1" name=""/>
-        <p:cNvGrpSpPr/>
-        <p:nvPr/>
-      </p:nvGrpSpPr>
-      <p:grpSpPr/>
-      <p:sp>
-        <p:nvSpPr>
-          <p:cNvPr id="2" name="Rectangle 1"/>
+              <a:t>TARGET OPENING</a:t>
+            </a:r>
+          </a:p>
+          <a:p>
+            <a:pPr>
+              <a:spcBef>
+                <a:spcPts val="600"/>
+              </a:spcBef>
+              <a:defRPr sz="1150">
+                <a:solidFill>
+                  <a:srgbClr val="FFFFFF"/>
+                </a:solidFill>
+                <a:latin typeface="Segoe UI"/>
+              </a:defRPr>
+            </a:pPr>
+            <a:r>
+              <a:t>Mục tiêu vận hành thử 05/12, khai trương chính thức trước 08/12.</a:t>
+            </a:r>
+          </a:p>
+        </p:txBody>
+      </p:sp>
+      <p:sp>
+        <p:nvSpPr>
+          <p:cNvPr id="6" name="Rounded Rectangle 5"/>
           <p:cNvSpPr/>
           <p:nvPr/>
         </p:nvSpPr>
         <p:spPr>
           <a:xfrm>
-            <a:off x="0" y="0"/>
-            <a:ext cx="12191695" cy="6858000"/>
+            <a:off x="3474720" y="1645920"/>
+            <a:ext cx="2514600" cy="4572000"/>
           </a:xfrm>
-          <a:prstGeom prst="rect">
+          <a:prstGeom prst="roundRect">
             <a:avLst/>
           </a:prstGeom>
           <a:solidFill>
-            <a:srgbClr val="F6F3EC"/>
+            <a:srgbClr val="1C2541"/>
           </a:solidFill>
-          <a:ln>
-            <a:noFill/>
+          <a:ln w="12700">
+            <a:solidFill>
+              <a:srgbClr val="3A506B"/>
+            </a:solidFill>
           </a:ln>
         </p:spPr>
         <p:style>
@@ -3355,14 +3527,14 @@
       </p:sp>
       <p:sp>
         <p:nvSpPr>
-          <p:cNvPr id="3" name="TextBox 2"/>
+          <p:cNvPr id="7" name="TextBox 6"/>
           <p:cNvSpPr txBox="1"/>
           <p:nvPr/>
         </p:nvSpPr>
         <p:spPr>
           <a:xfrm>
-            <a:off x="640080" y="502920"/>
-            <a:ext cx="10881360" cy="685800"/>
+            <a:off x="3703320" y="1828800"/>
+            <a:ext cx="2057400" cy="4206240"/>
           </a:xfrm>
           <a:prstGeom prst="rect">
             <a:avLst/>
@@ -3376,272 +3548,72 @@
           <a:lstStyle/>
           <a:p>
             <a:pPr>
-              <a:defRPr sz="2800" b="1">
-                <a:solidFill>
-                  <a:srgbClr val="12372A"/>
-                </a:solidFill>
-                <a:latin typeface="Aptos"/>
+              <a:defRPr sz="3200" b="1">
+                <a:solidFill>
+                  <a:srgbClr val="FFD166"/>
+                </a:solidFill>
+                <a:latin typeface="Segoe UI"/>
               </a:defRPr>
             </a:pPr>
             <a:r>
-              <a:t>Mục tiêu cuối tuần</a:t>
-            </a:r>
-          </a:p>
-        </p:txBody>
-      </p:sp>
-      <p:sp>
-        <p:nvSpPr>
-          <p:cNvPr id="4" name="TextBox 3"/>
-          <p:cNvSpPr txBox="1"/>
+              <a:t>1.2 TỶ</a:t>
+            </a:r>
+          </a:p>
+          <a:p>
+            <a:pPr>
+              <a:spcBef>
+                <a:spcPts val="400"/>
+              </a:spcBef>
+              <a:defRPr sz="1400" b="1">
+                <a:solidFill>
+                  <a:srgbClr val="FFFFFF"/>
+                </a:solidFill>
+                <a:latin typeface="Segoe UI"/>
+              </a:defRPr>
+            </a:pPr>
+            <a:r>
+              <a:t>TOTAL BUDGET</a:t>
+            </a:r>
+          </a:p>
+          <a:p>
+            <a:pPr>
+              <a:spcBef>
+                <a:spcPts val="600"/>
+              </a:spcBef>
+              <a:defRPr sz="1150">
+                <a:solidFill>
+                  <a:srgbClr val="FFFFFF"/>
+                </a:solidFill>
+                <a:latin typeface="Segoe UI"/>
+              </a:defRPr>
+            </a:pPr>
+            <a:r>
+              <a:t>Ngân sách tiêu chuẩn 1.2 tỷ VND (Dự phòng rủi ro 1.44 tỷ VND).</a:t>
+            </a:r>
+          </a:p>
+        </p:txBody>
+      </p:sp>
+      <p:sp>
+        <p:nvSpPr>
+          <p:cNvPr id="8" name="Rounded Rectangle 7"/>
+          <p:cNvSpPr/>
           <p:nvPr/>
         </p:nvSpPr>
         <p:spPr>
           <a:xfrm>
-            <a:off x="822960" y="1417320"/>
-            <a:ext cx="10515600" cy="566928"/>
+            <a:off x="6217920" y="1645920"/>
+            <a:ext cx="2514600" cy="4572000"/>
           </a:xfrm>
-          <a:prstGeom prst="rect">
-            <a:avLst/>
-          </a:prstGeom>
-          <a:noFill/>
-        </p:spPr>
-        <p:txBody>
-          <a:bodyPr wrap="square">
-            <a:spAutoFit/>
-          </a:bodyPr>
-          <a:lstStyle/>
-          <a:p>
-            <a:pPr>
-              <a:defRPr sz="1800" b="1">
-                <a:solidFill>
-                  <a:srgbClr val="0F5132"/>
-                </a:solidFill>
-                <a:latin typeface="Aptos"/>
-              </a:defRPr>
-            </a:pPr>
-            <a:r>
-              <a:t>• Khảo sát tối thiểu 8 mặt bằng</a:t>
-            </a:r>
-          </a:p>
-        </p:txBody>
-      </p:sp>
-      <p:sp>
-        <p:nvSpPr>
-          <p:cNvPr id="5" name="TextBox 4"/>
-          <p:cNvSpPr txBox="1"/>
-          <p:nvPr/>
-        </p:nvSpPr>
-        <p:spPr>
-          <a:xfrm>
-            <a:off x="822960" y="2084832"/>
-            <a:ext cx="10515600" cy="566928"/>
-          </a:xfrm>
-          <a:prstGeom prst="rect">
-            <a:avLst/>
-          </a:prstGeom>
-          <a:noFill/>
-        </p:spPr>
-        <p:txBody>
-          <a:bodyPr wrap="square">
-            <a:spAutoFit/>
-          </a:bodyPr>
-          <a:lstStyle/>
-          <a:p>
-            <a:pPr>
-              <a:defRPr sz="1800" b="0">
-                <a:solidFill>
-                  <a:srgbClr val="12372A"/>
-                </a:solidFill>
-                <a:latin typeface="Aptos"/>
-              </a:defRPr>
-            </a:pPr>
-            <a:r>
-              <a:t>• Shortlist 3–5 mặt bằng đạt điều kiện pháp lý, vận hành và không vi phạm flood line</a:t>
-            </a:r>
-          </a:p>
-        </p:txBody>
-      </p:sp>
-      <p:sp>
-        <p:nvSpPr>
-          <p:cNvPr id="6" name="TextBox 5"/>
-          <p:cNvSpPr txBox="1"/>
-          <p:nvPr/>
-        </p:nvSpPr>
-        <p:spPr>
-          <a:xfrm>
-            <a:off x="822960" y="2752344"/>
-            <a:ext cx="10515600" cy="566928"/>
-          </a:xfrm>
-          <a:prstGeom prst="rect">
-            <a:avLst/>
-          </a:prstGeom>
-          <a:noFill/>
-        </p:spPr>
-        <p:txBody>
-          <a:bodyPr wrap="square">
-            <a:spAutoFit/>
-          </a:bodyPr>
-          <a:lstStyle/>
-          <a:p>
-            <a:pPr>
-              <a:defRPr sz="1800" b="0">
-                <a:solidFill>
-                  <a:srgbClr val="12372A"/>
-                </a:solidFill>
-                <a:latin typeface="Aptos"/>
-              </a:defRPr>
-            </a:pPr>
-            <a:r>
-              <a:t>• Tasting ít nhất 5 SKU với tối thiểu 5 người chấm</a:t>
-            </a:r>
-          </a:p>
-        </p:txBody>
-      </p:sp>
-      <p:sp>
-        <p:nvSpPr>
-          <p:cNvPr id="7" name="TextBox 6"/>
-          <p:cNvSpPr txBox="1"/>
-          <p:nvPr/>
-        </p:nvSpPr>
-        <p:spPr>
-          <a:xfrm>
-            <a:off x="822960" y="3419856"/>
-            <a:ext cx="10515600" cy="566928"/>
-          </a:xfrm>
-          <a:prstGeom prst="rect">
-            <a:avLst/>
-          </a:prstGeom>
-          <a:noFill/>
-        </p:spPr>
-        <p:txBody>
-          <a:bodyPr wrap="square">
-            <a:spAutoFit/>
-          </a:bodyPr>
-          <a:lstStyle/>
-          <a:p>
-            <a:pPr>
-              <a:defRPr sz="1800" b="0">
-                <a:solidFill>
-                  <a:srgbClr val="12372A"/>
-                </a:solidFill>
-                <a:latin typeface="Aptos"/>
-              </a:defRPr>
-            </a:pPr>
-            <a:r>
-              <a:t>• Hoàn thiện Menu v1 kèm target COGS 34%</a:t>
-            </a:r>
-          </a:p>
-        </p:txBody>
-      </p:sp>
-      <p:sp>
-        <p:nvSpPr>
-          <p:cNvPr id="8" name="TextBox 7"/>
-          <p:cNvSpPr txBox="1"/>
-          <p:nvPr/>
-        </p:nvSpPr>
-        <p:spPr>
-          <a:xfrm>
-            <a:off x="822960" y="4087368"/>
-            <a:ext cx="10515600" cy="566928"/>
-          </a:xfrm>
-          <a:prstGeom prst="rect">
-            <a:avLst/>
-          </a:prstGeom>
-          <a:noFill/>
-        </p:spPr>
-        <p:txBody>
-          <a:bodyPr wrap="square">
-            <a:spAutoFit/>
-          </a:bodyPr>
-          <a:lstStyle/>
-          <a:p>
-            <a:pPr>
-              <a:defRPr sz="1800" b="0">
-                <a:solidFill>
-                  <a:srgbClr val="12372A"/>
-                </a:solidFill>
-                <a:latin typeface="Aptos"/>
-              </a:defRPr>
-            </a:pPr>
-            <a:r>
-              <a:t>• Xác minh trạng thái ERC, thuế và hóa đơn điện tử</a:t>
-            </a:r>
-          </a:p>
-        </p:txBody>
-      </p:sp>
-      <p:sp>
-        <p:nvSpPr>
-          <p:cNvPr id="9" name="TextBox 8"/>
-          <p:cNvSpPr txBox="1"/>
-          <p:nvPr/>
-        </p:nvSpPr>
-        <p:spPr>
-          <a:xfrm>
-            <a:off x="640080" y="6473952"/>
-            <a:ext cx="10881360" cy="201168"/>
-          </a:xfrm>
-          <a:prstGeom prst="rect">
-            <a:avLst/>
-          </a:prstGeom>
-          <a:noFill/>
-        </p:spPr>
-        <p:txBody>
-          <a:bodyPr wrap="square">
-            <a:spAutoFit/>
-          </a:bodyPr>
-          <a:lstStyle/>
-          <a:p>
-            <a:pPr>
-              <a:defRPr sz="900" b="0">
-                <a:solidFill>
-                  <a:srgbClr val="567064"/>
-                </a:solidFill>
-                <a:latin typeface="Aptos"/>
-              </a:defRPr>
-            </a:pPr>
-            <a:r>
-              <a:t>24–30/08/2026</a:t>
-            </a:r>
-          </a:p>
-        </p:txBody>
-      </p:sp>
-    </p:spTree>
-  </p:cSld>
-  <p:clrMapOvr>
-    <a:masterClrMapping/>
-  </p:clrMapOvr>
-</p:sld>
-</file>
-
-<file path=ppt/slides/slide3.xml><?xml version="1.0" encoding="utf-8"?>
-<p:sld xmlns:a="http://schemas.openxmlformats.org/drawingml/2006/main" xmlns:p="http://schemas.openxmlformats.org/presentationml/2006/main" xmlns:r="http://schemas.openxmlformats.org/officeDocument/2006/relationships">
-  <p:cSld>
-    <p:spTree>
-      <p:nvGrpSpPr>
-        <p:cNvPr id="1" name=""/>
-        <p:cNvGrpSpPr/>
-        <p:nvPr/>
-      </p:nvGrpSpPr>
-      <p:grpSpPr/>
-      <p:sp>
-        <p:nvSpPr>
-          <p:cNvPr id="2" name="Rectangle 1"/>
-          <p:cNvSpPr/>
-          <p:nvPr/>
-        </p:nvSpPr>
-        <p:spPr>
-          <a:xfrm>
-            <a:off x="0" y="0"/>
-            <a:ext cx="12191695" cy="6858000"/>
-          </a:xfrm>
-          <a:prstGeom prst="rect">
+          <a:prstGeom prst="roundRect">
             <a:avLst/>
           </a:prstGeom>
           <a:solidFill>
-            <a:srgbClr val="E8F0EA"/>
+            <a:srgbClr val="1C2541"/>
           </a:solidFill>
-          <a:ln>
-            <a:noFill/>
+          <a:ln w="12700">
+            <a:solidFill>
+              <a:srgbClr val="3A506B"/>
+            </a:solidFill>
           </a:ln>
         </p:spPr>
         <p:style>
@@ -3668,14 +3640,14 @@
       </p:sp>
       <p:sp>
         <p:nvSpPr>
-          <p:cNvPr id="3" name="TextBox 2"/>
+          <p:cNvPr id="9" name="TextBox 8"/>
           <p:cNvSpPr txBox="1"/>
           <p:nvPr/>
         </p:nvSpPr>
         <p:spPr>
           <a:xfrm>
-            <a:off x="640080" y="502920"/>
-            <a:ext cx="10881360" cy="685800"/>
+            <a:off x="6446520" y="1828800"/>
+            <a:ext cx="2057400" cy="4206240"/>
           </a:xfrm>
           <a:prstGeom prst="rect">
             <a:avLst/>
@@ -3689,272 +3661,72 @@
           <a:lstStyle/>
           <a:p>
             <a:pPr>
-              <a:defRPr sz="2800" b="1">
-                <a:solidFill>
-                  <a:srgbClr val="12372A"/>
-                </a:solidFill>
-                <a:latin typeface="Aptos"/>
+              <a:defRPr sz="3200" b="1">
+                <a:solidFill>
+                  <a:srgbClr val="06D6A0"/>
+                </a:solidFill>
+                <a:latin typeface="Segoe UI"/>
               </a:defRPr>
             </a:pPr>
             <a:r>
-              <a:t>Workstream 1 · Mặt bằng</a:t>
-            </a:r>
-          </a:p>
-        </p:txBody>
-      </p:sp>
-      <p:sp>
-        <p:nvSpPr>
-          <p:cNvPr id="4" name="TextBox 3"/>
-          <p:cNvSpPr txBox="1"/>
+              <a:t>143 TASKS</a:t>
+            </a:r>
+          </a:p>
+          <a:p>
+            <a:pPr>
+              <a:spcBef>
+                <a:spcPts val="400"/>
+              </a:spcBef>
+              <a:defRPr sz="1400" b="1">
+                <a:solidFill>
+                  <a:srgbClr val="FFFFFF"/>
+                </a:solidFill>
+                <a:latin typeface="Segoe UI"/>
+              </a:defRPr>
+            </a:pPr>
+            <a:r>
+              <a:t>TASK TRACKING</a:t>
+            </a:r>
+          </a:p>
+          <a:p>
+            <a:pPr>
+              <a:spcBef>
+                <a:spcPts val="600"/>
+              </a:spcBef>
+              <a:defRPr sz="1150">
+                <a:solidFill>
+                  <a:srgbClr val="FFFFFF"/>
+                </a:solidFill>
+                <a:latin typeface="Segoe UI"/>
+              </a:defRPr>
+            </a:pPr>
+            <a:r>
+              <a:t>Tổng cộng 143 đầu việc chia đều trong 16 tuần triển khai liên tục.</a:t>
+            </a:r>
+          </a:p>
+        </p:txBody>
+      </p:sp>
+      <p:sp>
+        <p:nvSpPr>
+          <p:cNvPr id="10" name="Rounded Rectangle 9"/>
+          <p:cNvSpPr/>
           <p:nvPr/>
         </p:nvSpPr>
         <p:spPr>
           <a:xfrm>
-            <a:off x="822960" y="1417320"/>
-            <a:ext cx="10515600" cy="566928"/>
+            <a:off x="8961120" y="1645920"/>
+            <a:ext cx="2514600" cy="4572000"/>
           </a:xfrm>
-          <a:prstGeom prst="rect">
-            <a:avLst/>
-          </a:prstGeom>
-          <a:noFill/>
-        </p:spPr>
-        <p:txBody>
-          <a:bodyPr wrap="square">
-            <a:spAutoFit/>
-          </a:bodyPr>
-          <a:lstStyle/>
-          <a:p>
-            <a:pPr>
-              <a:defRPr sz="1800" b="1">
-                <a:solidFill>
-                  <a:srgbClr val="12372A"/>
-                </a:solidFill>
-                <a:latin typeface="Aptos"/>
-              </a:defRPr>
-            </a:pPr>
-            <a:r>
-              <a:t>• Đặt lịch và hoàn tất ≥8 lượt khảo sát</a:t>
-            </a:r>
-          </a:p>
-        </p:txBody>
-      </p:sp>
-      <p:sp>
-        <p:nvSpPr>
-          <p:cNvPr id="5" name="TextBox 4"/>
-          <p:cNvSpPr txBox="1"/>
-          <p:nvPr/>
-        </p:nvSpPr>
-        <p:spPr>
-          <a:xfrm>
-            <a:off x="822960" y="2084832"/>
-            <a:ext cx="10515600" cy="566928"/>
-          </a:xfrm>
-          <a:prstGeom prst="rect">
-            <a:avLst/>
-          </a:prstGeom>
-          <a:noFill/>
-        </p:spPr>
-        <p:txBody>
-          <a:bodyPr wrap="square">
-            <a:spAutoFit/>
-          </a:bodyPr>
-          <a:lstStyle/>
-          <a:p>
-            <a:pPr>
-              <a:defRPr sz="1800" b="0">
-                <a:solidFill>
-                  <a:srgbClr val="12372A"/>
-                </a:solidFill>
-                <a:latin typeface="Aptos"/>
-              </a:defRPr>
-            </a:pPr>
-            <a:r>
-              <a:t>• Ghi địa chỉ, diện tích, giá thuê, mặt tiền, ảnh hiện trạng và nền nhà so với mặt đường</a:t>
-            </a:r>
-          </a:p>
-        </p:txBody>
-      </p:sp>
-      <p:sp>
-        <p:nvSpPr>
-          <p:cNvPr id="6" name="TextBox 5"/>
-          <p:cNvSpPr txBox="1"/>
-          <p:nvPr/>
-        </p:nvSpPr>
-        <p:spPr>
-          <a:xfrm>
-            <a:off x="822960" y="2752344"/>
-            <a:ext cx="10515600" cy="566928"/>
-          </a:xfrm>
-          <a:prstGeom prst="rect">
-            <a:avLst/>
-          </a:prstGeom>
-          <a:noFill/>
-        </p:spPr>
-        <p:txBody>
-          <a:bodyPr wrap="square">
-            <a:spAutoFit/>
-          </a:bodyPr>
-          <a:lstStyle/>
-          <a:p>
-            <a:pPr>
-              <a:defRPr sz="1800" b="0">
-                <a:solidFill>
-                  <a:srgbClr val="12372A"/>
-                </a:solidFill>
-                <a:latin typeface="Aptos"/>
-              </a:defRPr>
-            </a:pPr>
-            <a:r>
-              <a:t>• Kiểm tra sổ hồng, chủ cho thuê, quyền sử dụng thương mại và khả năng đăng ký kinh doanh</a:t>
-            </a:r>
-          </a:p>
-        </p:txBody>
-      </p:sp>
-      <p:sp>
-        <p:nvSpPr>
-          <p:cNvPr id="7" name="TextBox 6"/>
-          <p:cNvSpPr txBox="1"/>
-          <p:nvPr/>
-        </p:nvSpPr>
-        <p:spPr>
-          <a:xfrm>
-            <a:off x="822960" y="3419856"/>
-            <a:ext cx="10515600" cy="566928"/>
-          </a:xfrm>
-          <a:prstGeom prst="rect">
-            <a:avLst/>
-          </a:prstGeom>
-          <a:noFill/>
-        </p:spPr>
-        <p:txBody>
-          <a:bodyPr wrap="square">
-            <a:spAutoFit/>
-          </a:bodyPr>
-          <a:lstStyle/>
-          <a:p>
-            <a:pPr>
-              <a:defRPr sz="1800" b="0">
-                <a:solidFill>
-                  <a:srgbClr val="12372A"/>
-                </a:solidFill>
-                <a:latin typeface="Aptos"/>
-              </a:defRPr>
-            </a:pPr>
-            <a:r>
-              <a:t>• Kiểm tra điện 3 pha, nước/thoát nước, bẫy mỡ, biển hiệu và chỗ đậu xe</a:t>
-            </a:r>
-          </a:p>
-        </p:txBody>
-      </p:sp>
-      <p:sp>
-        <p:nvSpPr>
-          <p:cNvPr id="8" name="TextBox 7"/>
-          <p:cNvSpPr txBox="1"/>
-          <p:nvPr/>
-        </p:nvSpPr>
-        <p:spPr>
-          <a:xfrm>
-            <a:off x="822960" y="4087368"/>
-            <a:ext cx="10515600" cy="566928"/>
-          </a:xfrm>
-          <a:prstGeom prst="rect">
-            <a:avLst/>
-          </a:prstGeom>
-          <a:noFill/>
-        </p:spPr>
-        <p:txBody>
-          <a:bodyPr wrap="square">
-            <a:spAutoFit/>
-          </a:bodyPr>
-          <a:lstStyle/>
-          <a:p>
-            <a:pPr>
-              <a:defRPr sz="1800" b="0">
-                <a:solidFill>
-                  <a:srgbClr val="12372A"/>
-                </a:solidFill>
-                <a:latin typeface="Aptos"/>
-              </a:defRPr>
-            </a:pPr>
-            <a:r>
-              <a:t>• Chấm điểm và rút gọn còn 3–5 ứng viên</a:t>
-            </a:r>
-          </a:p>
-        </p:txBody>
-      </p:sp>
-      <p:sp>
-        <p:nvSpPr>
-          <p:cNvPr id="9" name="TextBox 8"/>
-          <p:cNvSpPr txBox="1"/>
-          <p:nvPr/>
-        </p:nvSpPr>
-        <p:spPr>
-          <a:xfrm>
-            <a:off x="640080" y="6473952"/>
-            <a:ext cx="10881360" cy="201168"/>
-          </a:xfrm>
-          <a:prstGeom prst="rect">
-            <a:avLst/>
-          </a:prstGeom>
-          <a:noFill/>
-        </p:spPr>
-        <p:txBody>
-          <a:bodyPr wrap="square">
-            <a:spAutoFit/>
-          </a:bodyPr>
-          <a:lstStyle/>
-          <a:p>
-            <a:pPr>
-              <a:defRPr sz="900" b="0">
-                <a:solidFill>
-                  <a:srgbClr val="567064"/>
-                </a:solidFill>
-                <a:latin typeface="Aptos"/>
-              </a:defRPr>
-            </a:pPr>
-            <a:r>
-              <a:t>Owner: Intern · Klaus tham gia 2–3 lượt quan trọng</a:t>
-            </a:r>
-          </a:p>
-        </p:txBody>
-      </p:sp>
-    </p:spTree>
-  </p:cSld>
-  <p:clrMapOvr>
-    <a:masterClrMapping/>
-  </p:clrMapOvr>
-</p:sld>
-</file>
-
-<file path=ppt/slides/slide4.xml><?xml version="1.0" encoding="utf-8"?>
-<p:sld xmlns:a="http://schemas.openxmlformats.org/drawingml/2006/main" xmlns:p="http://schemas.openxmlformats.org/presentationml/2006/main" xmlns:r="http://schemas.openxmlformats.org/officeDocument/2006/relationships">
-  <p:cSld>
-    <p:spTree>
-      <p:nvGrpSpPr>
-        <p:cNvPr id="1" name=""/>
-        <p:cNvGrpSpPr/>
-        <p:nvPr/>
-      </p:nvGrpSpPr>
-      <p:grpSpPr/>
-      <p:sp>
-        <p:nvSpPr>
-          <p:cNvPr id="2" name="Rectangle 1"/>
-          <p:cNvSpPr/>
-          <p:nvPr/>
-        </p:nvSpPr>
-        <p:spPr>
-          <a:xfrm>
-            <a:off x="0" y="0"/>
-            <a:ext cx="12191695" cy="6858000"/>
-          </a:xfrm>
-          <a:prstGeom prst="rect">
+          <a:prstGeom prst="roundRect">
             <a:avLst/>
           </a:prstGeom>
           <a:solidFill>
-            <a:srgbClr val="FFF1F0"/>
+            <a:srgbClr val="1C2541"/>
           </a:solidFill>
-          <a:ln>
-            <a:noFill/>
+          <a:ln w="12700">
+            <a:solidFill>
+              <a:srgbClr val="3A506B"/>
+            </a:solidFill>
           </a:ln>
         </p:spPr>
         <p:style>
@@ -3981,14 +3753,14 @@
       </p:sp>
       <p:sp>
         <p:nvSpPr>
-          <p:cNvPr id="3" name="TextBox 2"/>
+          <p:cNvPr id="11" name="TextBox 10"/>
           <p:cNvSpPr txBox="1"/>
           <p:nvPr/>
         </p:nvSpPr>
         <p:spPr>
           <a:xfrm>
-            <a:off x="640080" y="502920"/>
-            <a:ext cx="10881360" cy="685800"/>
+            <a:off x="9189720" y="1828800"/>
+            <a:ext cx="2057400" cy="4206240"/>
           </a:xfrm>
           <a:prstGeom prst="rect">
             <a:avLst/>
@@ -4002,231 +3774,47 @@
           <a:lstStyle/>
           <a:p>
             <a:pPr>
-              <a:defRPr sz="2800" b="1">
-                <a:solidFill>
-                  <a:srgbClr val="12372A"/>
-                </a:solidFill>
-                <a:latin typeface="Aptos"/>
+              <a:defRPr sz="3200" b="1">
+                <a:solidFill>
+                  <a:srgbClr val="EF476F"/>
+                </a:solidFill>
+                <a:latin typeface="Segoe UI"/>
               </a:defRPr>
             </a:pPr>
             <a:r>
-              <a:t>Gate bắt buộc · Flood &amp; pháp lý</a:t>
-            </a:r>
-          </a:p>
-        </p:txBody>
-      </p:sp>
-      <p:sp>
-        <p:nvSpPr>
-          <p:cNvPr id="4" name="TextBox 3"/>
-          <p:cNvSpPr txBox="1"/>
-          <p:nvPr/>
-        </p:nvSpPr>
-        <p:spPr>
-          <a:xfrm>
-            <a:off x="822960" y="1417320"/>
-            <a:ext cx="10515600" cy="566928"/>
-          </a:xfrm>
-          <a:prstGeom prst="rect">
-            <a:avLst/>
-          </a:prstGeom>
-          <a:noFill/>
-        </p:spPr>
-        <p:txBody>
-          <a:bodyPr wrap="square">
-            <a:spAutoFit/>
-          </a:bodyPr>
-          <a:lstStyle/>
+              <a:t>4 GATES</a:t>
+            </a:r>
+          </a:p>
           <a:p>
             <a:pPr>
-              <a:defRPr sz="1800" b="1">
-                <a:solidFill>
-                  <a:srgbClr val="B42318"/>
-                </a:solidFill>
-                <a:latin typeface="Aptos"/>
+              <a:spcBef>
+                <a:spcPts val="400"/>
+              </a:spcBef>
+              <a:defRPr sz="1400" b="1">
+                <a:solidFill>
+                  <a:srgbClr val="FFFFFF"/>
+                </a:solidFill>
+                <a:latin typeface="Segoe UI"/>
               </a:defRPr>
             </a:pPr>
             <a:r>
-              <a:t>• Không chọn mặt bằng dưới flood line Thảo Điền</a:t>
-            </a:r>
-          </a:p>
-        </p:txBody>
-      </p:sp>
-      <p:sp>
-        <p:nvSpPr>
-          <p:cNvPr id="5" name="TextBox 4"/>
-          <p:cNvSpPr txBox="1"/>
-          <p:nvPr/>
-        </p:nvSpPr>
-        <p:spPr>
-          <a:xfrm>
-            <a:off x="822960" y="2084832"/>
-            <a:ext cx="10515600" cy="566928"/>
-          </a:xfrm>
-          <a:prstGeom prst="rect">
-            <a:avLst/>
-          </a:prstGeom>
-          <a:noFill/>
-        </p:spPr>
-        <p:txBody>
-          <a:bodyPr wrap="square">
-            <a:spAutoFit/>
-          </a:bodyPr>
-          <a:lstStyle/>
+              <a:t>HARD GATES</a:t>
+            </a:r>
+          </a:p>
           <a:p>
             <a:pPr>
-              <a:defRPr sz="1800" b="0">
-                <a:solidFill>
-                  <a:srgbClr val="12372A"/>
-                </a:solidFill>
-                <a:latin typeface="Aptos"/>
+              <a:spcBef>
+                <a:spcPts val="600"/>
+              </a:spcBef>
+              <a:defRPr sz="1150">
+                <a:solidFill>
+                  <a:srgbClr val="FFFFFF"/>
+                </a:solidFill>
+                <a:latin typeface="Segoe UI"/>
               </a:defRPr>
             </a:pPr>
             <a:r>
-              <a:t>• Kiểm tra dấu nước/ngấn ngập; nếu có thể, tái kiểm tra sau mưa lớn</a:t>
-            </a:r>
-          </a:p>
-        </p:txBody>
-      </p:sp>
-      <p:sp>
-        <p:nvSpPr>
-          <p:cNvPr id="6" name="TextBox 5"/>
-          <p:cNvSpPr txBox="1"/>
-          <p:nvPr/>
-        </p:nvSpPr>
-        <p:spPr>
-          <a:xfrm>
-            <a:off x="822960" y="2752344"/>
-            <a:ext cx="10515600" cy="566928"/>
-          </a:xfrm>
-          <a:prstGeom prst="rect">
-            <a:avLst/>
-          </a:prstGeom>
-          <a:noFill/>
-        </p:spPr>
-        <p:txBody>
-          <a:bodyPr wrap="square">
-            <a:spAutoFit/>
-          </a:bodyPr>
-          <a:lstStyle/>
-          <a:p>
-            <a:pPr>
-              <a:defRPr sz="1800" b="0">
-                <a:solidFill>
-                  <a:srgbClr val="12372A"/>
-                </a:solidFill>
-                <a:latin typeface="Aptos"/>
-              </a:defRPr>
-            </a:pPr>
-            <a:r>
-              <a:t>• Chụp ảnh nền, mặt đường, lối vào và hệ thống thoát nước</a:t>
-            </a:r>
-          </a:p>
-        </p:txBody>
-      </p:sp>
-      <p:sp>
-        <p:nvSpPr>
-          <p:cNvPr id="7" name="TextBox 6"/>
-          <p:cNvSpPr txBox="1"/>
-          <p:nvPr/>
-        </p:nvSpPr>
-        <p:spPr>
-          <a:xfrm>
-            <a:off x="822960" y="3419856"/>
-            <a:ext cx="10515600" cy="566928"/>
-          </a:xfrm>
-          <a:prstGeom prst="rect">
-            <a:avLst/>
-          </a:prstGeom>
-          <a:noFill/>
-        </p:spPr>
-        <p:txBody>
-          <a:bodyPr wrap="square">
-            <a:spAutoFit/>
-          </a:bodyPr>
-          <a:lstStyle/>
-          <a:p>
-            <a:pPr>
-              <a:defRPr sz="1800" b="0">
-                <a:solidFill>
-                  <a:srgbClr val="12372A"/>
-                </a:solidFill>
-                <a:latin typeface="Aptos"/>
-              </a:defRPr>
-            </a:pPr>
-            <a:r>
-              <a:t>• Loại ngay mặt bằng có rủi ro ngập hoặc hồ sơ đăng ký kinh doanh không rõ</a:t>
-            </a:r>
-          </a:p>
-        </p:txBody>
-      </p:sp>
-      <p:sp>
-        <p:nvSpPr>
-          <p:cNvPr id="8" name="TextBox 7"/>
-          <p:cNvSpPr txBox="1"/>
-          <p:nvPr/>
-        </p:nvSpPr>
-        <p:spPr>
-          <a:xfrm>
-            <a:off x="822960" y="4087368"/>
-            <a:ext cx="10515600" cy="566928"/>
-          </a:xfrm>
-          <a:prstGeom prst="rect">
-            <a:avLst/>
-          </a:prstGeom>
-          <a:noFill/>
-        </p:spPr>
-        <p:txBody>
-          <a:bodyPr wrap="square">
-            <a:spAutoFit/>
-          </a:bodyPr>
-          <a:lstStyle/>
-          <a:p>
-            <a:pPr>
-              <a:defRPr sz="1800" b="0">
-                <a:solidFill>
-                  <a:srgbClr val="12372A"/>
-                </a:solidFill>
-                <a:latin typeface="Aptos"/>
-              </a:defRPr>
-            </a:pPr>
-            <a:r>
-              <a:t>• Đối chiếu: flood risk · legal cleanliness · rent · frontage · gym catchment</a:t>
-            </a:r>
-          </a:p>
-        </p:txBody>
-      </p:sp>
-      <p:sp>
-        <p:nvSpPr>
-          <p:cNvPr id="9" name="TextBox 8"/>
-          <p:cNvSpPr txBox="1"/>
-          <p:nvPr/>
-        </p:nvSpPr>
-        <p:spPr>
-          <a:xfrm>
-            <a:off x="640080" y="6473952"/>
-            <a:ext cx="10881360" cy="201168"/>
-          </a:xfrm>
-          <a:prstGeom prst="rect">
-            <a:avLst/>
-          </a:prstGeom>
-          <a:noFill/>
-        </p:spPr>
-        <p:txBody>
-          <a:bodyPr wrap="square">
-            <a:spAutoFit/>
-          </a:bodyPr>
-          <a:lstStyle/>
-          <a:p>
-            <a:pPr>
-              <a:defRPr sz="900" b="0">
-                <a:solidFill>
-                  <a:srgbClr val="567064"/>
-                </a:solidFill>
-                <a:latin typeface="Aptos"/>
-              </a:defRPr>
-            </a:pPr>
-            <a:r>
-              <a:t>Decision rule: fail flood/legal = no-go</a:t>
+              <a:t>3 Cổng pháp lý bắt buộc: ĐKKD (Tuần 4), ATVSTP (Tuần 8), PCCC (Tuần 8).</a:t>
             </a:r>
           </a:p>
         </p:txBody>
@@ -4239,9 +3827,17 @@
 </p:sld>
 </file>
 
-<file path=ppt/slides/slide5.xml><?xml version="1.0" encoding="utf-8"?>
+<file path=ppt/slides/slide3.xml><?xml version="1.0" encoding="utf-8"?>
 <p:sld xmlns:a="http://schemas.openxmlformats.org/drawingml/2006/main" xmlns:p="http://schemas.openxmlformats.org/presentationml/2006/main" xmlns:r="http://schemas.openxmlformats.org/officeDocument/2006/relationships">
   <p:cSld>
+    <p:bg>
+      <p:bgPr>
+        <a:solidFill>
+          <a:srgbClr val="0B132B"/>
+        </a:solidFill>
+        <a:effectLst/>
+      </p:bgPr>
+    </p:bg>
     <p:spTree>
       <p:nvGrpSpPr>
         <p:cNvPr id="1" name=""/>
@@ -4251,23 +3847,97 @@
       <p:grpSpPr/>
       <p:sp>
         <p:nvSpPr>
-          <p:cNvPr id="2" name="Rectangle 1"/>
-          <p:cNvSpPr/>
+          <p:cNvPr id="2" name="TextBox 1"/>
+          <p:cNvSpPr txBox="1"/>
           <p:nvPr/>
         </p:nvSpPr>
         <p:spPr>
           <a:xfrm>
-            <a:off x="0" y="0"/>
-            <a:ext cx="12191695" cy="6858000"/>
+            <a:off x="731520" y="365760"/>
+            <a:ext cx="10698480" cy="320040"/>
           </a:xfrm>
           <a:prstGeom prst="rect">
             <a:avLst/>
           </a:prstGeom>
+          <a:noFill/>
+        </p:spPr>
+        <p:txBody>
+          <a:bodyPr wrap="none">
+            <a:spAutoFit/>
+          </a:bodyPr>
+          <a:lstStyle/>
+          <a:p>
+            <a:pPr>
+              <a:defRPr sz="1100" b="1">
+                <a:solidFill>
+                  <a:srgbClr val="48CAE4"/>
+                </a:solidFill>
+                <a:latin typeface="Segoe UI"/>
+              </a:defRPr>
+            </a:pPr>
+            <a:r>
+              <a:t>PROTEIN BAR THẢO ĐIỀN — WEEK 3 OPERATIONS</a:t>
+            </a:r>
+          </a:p>
+        </p:txBody>
+      </p:sp>
+      <p:sp>
+        <p:nvSpPr>
+          <p:cNvPr id="3" name="TextBox 2"/>
+          <p:cNvSpPr txBox="1"/>
+          <p:nvPr/>
+        </p:nvSpPr>
+        <p:spPr>
+          <a:xfrm>
+            <a:off x="731520" y="640080"/>
+            <a:ext cx="10698480" cy="731520"/>
+          </a:xfrm>
+          <a:prstGeom prst="rect">
+            <a:avLst/>
+          </a:prstGeom>
+          <a:noFill/>
+        </p:spPr>
+        <p:txBody>
+          <a:bodyPr wrap="none">
+            <a:spAutoFit/>
+          </a:bodyPr>
+          <a:lstStyle/>
+          <a:p>
+            <a:pPr>
+              <a:defRPr sz="2200" b="1">
+                <a:solidFill>
+                  <a:srgbClr val="FFFFFF"/>
+                </a:solidFill>
+                <a:latin typeface="Segoe UI"/>
+              </a:defRPr>
+            </a:pPr>
+            <a:r>
+              <a:t>Chi Tiết 4 Nhóm Công Việc Tuần 3 (24/08 – 30/08)</a:t>
+            </a:r>
+          </a:p>
+        </p:txBody>
+      </p:sp>
+      <p:sp>
+        <p:nvSpPr>
+          <p:cNvPr id="4" name="Rounded Rectangle 3"/>
+          <p:cNvSpPr/>
+          <p:nvPr/>
+        </p:nvSpPr>
+        <p:spPr>
+          <a:xfrm>
+            <a:off x="731520" y="1645920"/>
+            <a:ext cx="5212080" cy="2194560"/>
+          </a:xfrm>
+          <a:prstGeom prst="roundRect">
+            <a:avLst/>
+          </a:prstGeom>
           <a:solidFill>
-            <a:srgbClr val="F6F3EC"/>
+            <a:srgbClr val="1C2541"/>
           </a:solidFill>
-          <a:ln>
-            <a:noFill/>
+          <a:ln w="12700">
+            <a:solidFill>
+              <a:srgbClr val="3A506B"/>
+            </a:solidFill>
           </a:ln>
         </p:spPr>
         <p:style>
@@ -4294,14 +3964,14 @@
       </p:sp>
       <p:sp>
         <p:nvSpPr>
-          <p:cNvPr id="3" name="TextBox 2"/>
+          <p:cNvPr id="5" name="TextBox 4"/>
           <p:cNvSpPr txBox="1"/>
           <p:nvPr/>
         </p:nvSpPr>
         <p:spPr>
           <a:xfrm>
-            <a:off x="640080" y="502920"/>
-            <a:ext cx="10881360" cy="685800"/>
+            <a:off x="960120" y="1828800"/>
+            <a:ext cx="4754880" cy="1828800"/>
           </a:xfrm>
           <a:prstGeom prst="rect">
             <a:avLst/>
@@ -4315,308 +3985,64 @@
           <a:lstStyle/>
           <a:p>
             <a:pPr>
-              <a:defRPr sz="2800" b="1">
-                <a:solidFill>
-                  <a:srgbClr val="12372A"/>
-                </a:solidFill>
-                <a:latin typeface="Aptos"/>
+              <a:defRPr sz="1500" b="1">
+                <a:solidFill>
+                  <a:srgbClr val="48CAE4"/>
+                </a:solidFill>
+                <a:latin typeface="Segoe UI"/>
               </a:defRPr>
             </a:pPr>
             <a:r>
-              <a:t>Workstream 2 · Supplier tasting</a:t>
-            </a:r>
-          </a:p>
-        </p:txBody>
-      </p:sp>
-      <p:sp>
-        <p:nvSpPr>
-          <p:cNvPr id="4" name="TextBox 3"/>
-          <p:cNvSpPr txBox="1"/>
+              <a:t>1. Khảo Sát &amp; Chốt Mặt Bằng (Thảo Điền)</a:t>
+            </a:r>
+          </a:p>
+          <a:p>
+            <a:pPr>
+              <a:spcBef>
+                <a:spcPts val="600"/>
+              </a:spcBef>
+              <a:defRPr sz="1150">
+                <a:solidFill>
+                  <a:srgbClr val="FFFFFF"/>
+                </a:solidFill>
+                <a:latin typeface="Segoe UI"/>
+              </a:defRPr>
+            </a:pPr>
+            <a:r>
+              <a:t>• Kiểm tra lịch sử ngập triều cường tại vị trí thuê.</a:t>
+            </a:r>
+            <a:br/>
+            <a:r>
+              <a:t>• Đàm phán thời gian fit-out miễn phí 30–45 ngày.</a:t>
+            </a:r>
+            <a:br/>
+            <a:r>
+              <a:t>• Xác minh giấy tờ quyền sở hữu hợp pháp của chủ nhà.</a:t>
+            </a:r>
+          </a:p>
+        </p:txBody>
+      </p:sp>
+      <p:sp>
+        <p:nvSpPr>
+          <p:cNvPr id="6" name="Rounded Rectangle 5"/>
+          <p:cNvSpPr/>
           <p:nvPr/>
         </p:nvSpPr>
         <p:spPr>
           <a:xfrm>
-            <a:off x="822960" y="1417320"/>
-            <a:ext cx="10515600" cy="566928"/>
+            <a:off x="6217920" y="1645920"/>
+            <a:ext cx="5212080" cy="2194560"/>
           </a:xfrm>
-          <a:prstGeom prst="rect">
-            <a:avLst/>
-          </a:prstGeom>
-          <a:noFill/>
-        </p:spPr>
-        <p:txBody>
-          <a:bodyPr wrap="square">
-            <a:spAutoFit/>
-          </a:bodyPr>
-          <a:lstStyle/>
-          <a:p>
-            <a:pPr>
-              <a:defRPr sz="1800" b="1">
-                <a:solidFill>
-                  <a:srgbClr val="12372A"/>
-                </a:solidFill>
-                <a:latin typeface="Aptos"/>
-              </a:defRPr>
-            </a:pPr>
-            <a:r>
-              <a:t>• Tổ chức tasting #1: ≥5 SKU · ≥5 tasters · blind format</a:t>
-            </a:r>
-          </a:p>
-        </p:txBody>
-      </p:sp>
-      <p:sp>
-        <p:nvSpPr>
-          <p:cNvPr id="5" name="TextBox 4"/>
-          <p:cNvSpPr txBox="1"/>
-          <p:nvPr/>
-        </p:nvSpPr>
-        <p:spPr>
-          <a:xfrm>
-            <a:off x="822960" y="2084832"/>
-            <a:ext cx="10515600" cy="566928"/>
-          </a:xfrm>
-          <a:prstGeom prst="rect">
-            <a:avLst/>
-          </a:prstGeom>
-          <a:noFill/>
-        </p:spPr>
-        <p:txBody>
-          <a:bodyPr wrap="square">
-            <a:spAutoFit/>
-          </a:bodyPr>
-          <a:lstStyle/>
-          <a:p>
-            <a:pPr>
-              <a:defRPr sz="1800" b="0">
-                <a:solidFill>
-                  <a:srgbClr val="12372A"/>
-                </a:solidFill>
-                <a:latin typeface="Aptos"/>
-              </a:defRPr>
-            </a:pPr>
-            <a:r>
-              <a:t>• Chấm hương vị và khả năng phù hợp menu</a:t>
-            </a:r>
-          </a:p>
-        </p:txBody>
-      </p:sp>
-      <p:sp>
-        <p:nvSpPr>
-          <p:cNvPr id="6" name="TextBox 5"/>
-          <p:cNvSpPr txBox="1"/>
-          <p:nvPr/>
-        </p:nvSpPr>
-        <p:spPr>
-          <a:xfrm>
-            <a:off x="822960" y="2752344"/>
-            <a:ext cx="10515600" cy="566928"/>
-          </a:xfrm>
-          <a:prstGeom prst="rect">
-            <a:avLst/>
-          </a:prstGeom>
-          <a:noFill/>
-        </p:spPr>
-        <p:txBody>
-          <a:bodyPr wrap="square">
-            <a:spAutoFit/>
-          </a:bodyPr>
-          <a:lstStyle/>
-          <a:p>
-            <a:pPr>
-              <a:defRPr sz="1800" b="0">
-                <a:solidFill>
-                  <a:srgbClr val="12372A"/>
-                </a:solidFill>
-                <a:latin typeface="Aptos"/>
-              </a:defRPr>
-            </a:pPr>
-            <a:r>
-              <a:t>• Ghi protein (g/serving) và tính VND trên mỗi gram protein</a:t>
-            </a:r>
-          </a:p>
-        </p:txBody>
-      </p:sp>
-      <p:sp>
-        <p:nvSpPr>
-          <p:cNvPr id="7" name="TextBox 6"/>
-          <p:cNvSpPr txBox="1"/>
-          <p:nvPr/>
-        </p:nvSpPr>
-        <p:spPr>
-          <a:xfrm>
-            <a:off x="822960" y="3419856"/>
-            <a:ext cx="10515600" cy="566928"/>
-          </a:xfrm>
-          <a:prstGeom prst="rect">
-            <a:avLst/>
-          </a:prstGeom>
-          <a:noFill/>
-        </p:spPr>
-        <p:txBody>
-          <a:bodyPr wrap="square">
-            <a:spAutoFit/>
-          </a:bodyPr>
-          <a:lstStyle/>
-          <a:p>
-            <a:pPr>
-              <a:defRPr sz="1800" b="0">
-                <a:solidFill>
-                  <a:srgbClr val="12372A"/>
-                </a:solidFill>
-                <a:latin typeface="Aptos"/>
-              </a:defRPr>
-            </a:pPr>
-            <a:r>
-              <a:t>• Đánh giá margin, độ ổn định nguồn cung và lead time</a:t>
-            </a:r>
-          </a:p>
-        </p:txBody>
-      </p:sp>
-      <p:sp>
-        <p:nvSpPr>
-          <p:cNvPr id="8" name="TextBox 7"/>
-          <p:cNvSpPr txBox="1"/>
-          <p:nvPr/>
-        </p:nvSpPr>
-        <p:spPr>
-          <a:xfrm>
-            <a:off x="822960" y="4087368"/>
-            <a:ext cx="10515600" cy="566928"/>
-          </a:xfrm>
-          <a:prstGeom prst="rect">
-            <a:avLst/>
-          </a:prstGeom>
-          <a:noFill/>
-        </p:spPr>
-        <p:txBody>
-          <a:bodyPr wrap="square">
-            <a:spAutoFit/>
-          </a:bodyPr>
-          <a:lstStyle/>
-          <a:p>
-            <a:pPr>
-              <a:defRPr sz="1800" b="0">
-                <a:solidFill>
-                  <a:srgbClr val="12372A"/>
-                </a:solidFill>
-                <a:latin typeface="Aptos"/>
-              </a:defRPr>
-            </a:pPr>
-            <a:r>
-              <a:t>• Yêu cầu bảng giá và bản tự công bố cho từng SKU</a:t>
-            </a:r>
-          </a:p>
-        </p:txBody>
-      </p:sp>
-      <p:sp>
-        <p:nvSpPr>
-          <p:cNvPr id="9" name="TextBox 8"/>
-          <p:cNvSpPr txBox="1"/>
-          <p:nvPr/>
-        </p:nvSpPr>
-        <p:spPr>
-          <a:xfrm>
-            <a:off x="822960" y="4754880"/>
-            <a:ext cx="10515600" cy="566928"/>
-          </a:xfrm>
-          <a:prstGeom prst="rect">
-            <a:avLst/>
-          </a:prstGeom>
-          <a:noFill/>
-        </p:spPr>
-        <p:txBody>
-          <a:bodyPr wrap="square">
-            <a:spAutoFit/>
-          </a:bodyPr>
-          <a:lstStyle/>
-          <a:p>
-            <a:pPr>
-              <a:defRPr sz="1800" b="1">
-                <a:solidFill>
-                  <a:srgbClr val="B42318"/>
-                </a:solidFill>
-                <a:latin typeface="Aptos"/>
-              </a:defRPr>
-            </a:pPr>
-            <a:r>
-              <a:t>• Không có declaration copy = SKU chưa được đưa vào shortlist bán hàng</a:t>
-            </a:r>
-          </a:p>
-        </p:txBody>
-      </p:sp>
-      <p:sp>
-        <p:nvSpPr>
-          <p:cNvPr id="10" name="TextBox 9"/>
-          <p:cNvSpPr txBox="1"/>
-          <p:nvPr/>
-        </p:nvSpPr>
-        <p:spPr>
-          <a:xfrm>
-            <a:off x="640080" y="6473952"/>
-            <a:ext cx="10881360" cy="201168"/>
-          </a:xfrm>
-          <a:prstGeom prst="rect">
-            <a:avLst/>
-          </a:prstGeom>
-          <a:noFill/>
-        </p:spPr>
-        <p:txBody>
-          <a:bodyPr wrap="square">
-            <a:spAutoFit/>
-          </a:bodyPr>
-          <a:lstStyle/>
-          <a:p>
-            <a:pPr>
-              <a:defRPr sz="900" b="0">
-                <a:solidFill>
-                  <a:srgbClr val="567064"/>
-                </a:solidFill>
-                <a:latin typeface="Aptos"/>
-              </a:defRPr>
-            </a:pPr>
-            <a:r>
-              <a:t>Owner: Intern + Klaus · Output: scorecard ≥5 SKU</a:t>
-            </a:r>
-          </a:p>
-        </p:txBody>
-      </p:sp>
-    </p:spTree>
-  </p:cSld>
-  <p:clrMapOvr>
-    <a:masterClrMapping/>
-  </p:clrMapOvr>
-</p:sld>
-</file>
-
-<file path=ppt/slides/slide6.xml><?xml version="1.0" encoding="utf-8"?>
-<p:sld xmlns:a="http://schemas.openxmlformats.org/drawingml/2006/main" xmlns:p="http://schemas.openxmlformats.org/presentationml/2006/main" xmlns:r="http://schemas.openxmlformats.org/officeDocument/2006/relationships">
-  <p:cSld>
-    <p:spTree>
-      <p:nvGrpSpPr>
-        <p:cNvPr id="1" name=""/>
-        <p:cNvGrpSpPr/>
-        <p:nvPr/>
-      </p:nvGrpSpPr>
-      <p:grpSpPr/>
-      <p:sp>
-        <p:nvSpPr>
-          <p:cNvPr id="2" name="Rectangle 1"/>
-          <p:cNvSpPr/>
-          <p:nvPr/>
-        </p:nvSpPr>
-        <p:spPr>
-          <a:xfrm>
-            <a:off x="0" y="0"/>
-            <a:ext cx="12191695" cy="6858000"/>
-          </a:xfrm>
-          <a:prstGeom prst="rect">
+          <a:prstGeom prst="roundRect">
             <a:avLst/>
           </a:prstGeom>
           <a:solidFill>
-            <a:srgbClr val="E8F0EA"/>
+            <a:srgbClr val="1C2541"/>
           </a:solidFill>
-          <a:ln>
-            <a:noFill/>
+          <a:ln w="12700">
+            <a:solidFill>
+              <a:srgbClr val="3A506B"/>
+            </a:solidFill>
           </a:ln>
         </p:spPr>
         <p:style>
@@ -4643,14 +4069,14 @@
       </p:sp>
       <p:sp>
         <p:nvSpPr>
-          <p:cNvPr id="3" name="TextBox 2"/>
+          <p:cNvPr id="7" name="TextBox 6"/>
           <p:cNvSpPr txBox="1"/>
           <p:nvPr/>
         </p:nvSpPr>
         <p:spPr>
           <a:xfrm>
-            <a:off x="640080" y="502920"/>
-            <a:ext cx="10881360" cy="685800"/>
+            <a:off x="6446520" y="1828800"/>
+            <a:ext cx="4754880" cy="1828800"/>
           </a:xfrm>
           <a:prstGeom prst="rect">
             <a:avLst/>
@@ -4664,308 +4090,64 @@
           <a:lstStyle/>
           <a:p>
             <a:pPr>
-              <a:defRPr sz="2800" b="1">
-                <a:solidFill>
-                  <a:srgbClr val="12372A"/>
-                </a:solidFill>
-                <a:latin typeface="Aptos"/>
+              <a:defRPr sz="1500" b="1">
+                <a:solidFill>
+                  <a:srgbClr val="06D6A0"/>
+                </a:solidFill>
+                <a:latin typeface="Segoe UI"/>
               </a:defRPr>
             </a:pPr>
             <a:r>
-              <a:t>Workstream 3 · Menu &amp; tài chính</a:t>
-            </a:r>
-          </a:p>
-        </p:txBody>
-      </p:sp>
-      <p:sp>
-        <p:nvSpPr>
-          <p:cNvPr id="4" name="TextBox 3"/>
-          <p:cNvSpPr txBox="1"/>
+              <a:t>2. Pháp Lý &amp; Thành Lập Doanh Nghiệp</a:t>
+            </a:r>
+          </a:p>
+          <a:p>
+            <a:pPr>
+              <a:spcBef>
+                <a:spcPts val="600"/>
+              </a:spcBef>
+              <a:defRPr sz="1150">
+                <a:solidFill>
+                  <a:srgbClr val="FFFFFF"/>
+                </a:solidFill>
+                <a:latin typeface="Segoe UI"/>
+              </a:defRPr>
+            </a:pPr>
+            <a:r>
+              <a:t>• Nộp hồ sơ thành lập Công ty TNHH 2TV tại Sở KH&amp;ĐT.</a:t>
+            </a:r>
+            <a:br/>
+            <a:r>
+              <a:t>• Chuẩn bị đăng ký ngành nghề F&amp;B, bán lẻ thực phẩm bổ sung.</a:t>
+            </a:r>
+            <a:br/>
+            <a:r>
+              <a:t>• Chuẩn bị hồ sơ cơ sở đủ điều kiện ATVSTP.</a:t>
+            </a:r>
+          </a:p>
+        </p:txBody>
+      </p:sp>
+      <p:sp>
+        <p:nvSpPr>
+          <p:cNvPr id="8" name="Rounded Rectangle 7"/>
+          <p:cNvSpPr/>
           <p:nvPr/>
         </p:nvSpPr>
         <p:spPr>
           <a:xfrm>
-            <a:off x="822960" y="1417320"/>
-            <a:ext cx="10515600" cy="566928"/>
+            <a:off x="731520" y="4114800"/>
+            <a:ext cx="5212080" cy="2194560"/>
           </a:xfrm>
-          <a:prstGeom prst="rect">
-            <a:avLst/>
-          </a:prstGeom>
-          <a:noFill/>
-        </p:spPr>
-        <p:txBody>
-          <a:bodyPr wrap="square">
-            <a:spAutoFit/>
-          </a:bodyPr>
-          <a:lstStyle/>
-          <a:p>
-            <a:pPr>
-              <a:defRPr sz="1800" b="1">
-                <a:solidFill>
-                  <a:srgbClr val="12372A"/>
-                </a:solidFill>
-                <a:latin typeface="Aptos"/>
-              </a:defRPr>
-            </a:pPr>
-            <a:r>
-              <a:t>• Hoàn thiện Menu v1</a:t>
-            </a:r>
-          </a:p>
-        </p:txBody>
-      </p:sp>
-      <p:sp>
-        <p:nvSpPr>
-          <p:cNvPr id="5" name="TextBox 4"/>
-          <p:cNvSpPr txBox="1"/>
-          <p:nvPr/>
-        </p:nvSpPr>
-        <p:spPr>
-          <a:xfrm>
-            <a:off x="822960" y="2084832"/>
-            <a:ext cx="10515600" cy="566928"/>
-          </a:xfrm>
-          <a:prstGeom prst="rect">
-            <a:avLst/>
-          </a:prstGeom>
-          <a:noFill/>
-        </p:spPr>
-        <p:txBody>
-          <a:bodyPr wrap="square">
-            <a:spAutoFit/>
-          </a:bodyPr>
-          <a:lstStyle/>
-          <a:p>
-            <a:pPr>
-              <a:defRPr sz="1800" b="0">
-                <a:solidFill>
-                  <a:srgbClr val="12372A"/>
-                </a:solidFill>
-                <a:latin typeface="Aptos"/>
-              </a:defRPr>
-            </a:pPr>
-            <a:r>
-              <a:t>• Protein shake ≥25g · proffee · protein iced tea</a:t>
-            </a:r>
-          </a:p>
-        </p:txBody>
-      </p:sp>
-      <p:sp>
-        <p:nvSpPr>
-          <p:cNvPr id="6" name="TextBox 5"/>
-          <p:cNvSpPr txBox="1"/>
-          <p:nvPr/>
-        </p:nvSpPr>
-        <p:spPr>
-          <a:xfrm>
-            <a:off x="822960" y="2752344"/>
-            <a:ext cx="10515600" cy="566928"/>
-          </a:xfrm>
-          <a:prstGeom prst="rect">
-            <a:avLst/>
-          </a:prstGeom>
-          <a:noFill/>
-        </p:spPr>
-        <p:txBody>
-          <a:bodyPr wrap="square">
-            <a:spAutoFit/>
-          </a:bodyPr>
-          <a:lstStyle/>
-          <a:p>
-            <a:pPr>
-              <a:defRPr sz="1800" b="0">
-                <a:solidFill>
-                  <a:srgbClr val="12372A"/>
-                </a:solidFill>
-                <a:latin typeface="Aptos"/>
-              </a:defRPr>
-            </a:pPr>
-            <a:r>
-              <a:t>• 3–4 món bowl/wrap · grab-and-go RTD từ tủ lạnh</a:t>
-            </a:r>
-          </a:p>
-        </p:txBody>
-      </p:sp>
-      <p:sp>
-        <p:nvSpPr>
-          <p:cNvPr id="7" name="TextBox 6"/>
-          <p:cNvSpPr txBox="1"/>
-          <p:nvPr/>
-        </p:nvSpPr>
-        <p:spPr>
-          <a:xfrm>
-            <a:off x="822960" y="3419856"/>
-            <a:ext cx="10515600" cy="566928"/>
-          </a:xfrm>
-          <a:prstGeom prst="rect">
-            <a:avLst/>
-          </a:prstGeom>
-          <a:noFill/>
-        </p:spPr>
-        <p:txBody>
-          <a:bodyPr wrap="square">
-            <a:spAutoFit/>
-          </a:bodyPr>
-          <a:lstStyle/>
-          <a:p>
-            <a:pPr>
-              <a:defRPr sz="1800" b="0">
-                <a:solidFill>
-                  <a:srgbClr val="12372A"/>
-                </a:solidFill>
-                <a:latin typeface="Aptos"/>
-              </a:defRPr>
-            </a:pPr>
-            <a:r>
-              <a:t>• Tính COGS từng món theo giả định P&amp;L: 34%</a:t>
-            </a:r>
-          </a:p>
-        </p:txBody>
-      </p:sp>
-      <p:sp>
-        <p:nvSpPr>
-          <p:cNvPr id="8" name="TextBox 7"/>
-          <p:cNvSpPr txBox="1"/>
-          <p:nvPr/>
-        </p:nvSpPr>
-        <p:spPr>
-          <a:xfrm>
-            <a:off x="822960" y="4087368"/>
-            <a:ext cx="10515600" cy="566928"/>
-          </a:xfrm>
-          <a:prstGeom prst="rect">
-            <a:avLst/>
-          </a:prstGeom>
-          <a:noFill/>
-        </p:spPr>
-        <p:txBody>
-          <a:bodyPr wrap="square">
-            <a:spAutoFit/>
-          </a:bodyPr>
-          <a:lstStyle/>
-          <a:p>
-            <a:pPr>
-              <a:defRPr sz="1800" b="0">
-                <a:solidFill>
-                  <a:srgbClr val="12372A"/>
-                </a:solidFill>
-                <a:latin typeface="Aptos"/>
-              </a:defRPr>
-            </a:pPr>
-            <a:r>
-              <a:t>• Gắn mỗi món với supplier/SKU, giá vốn, protein và target selling price</a:t>
-            </a:r>
-          </a:p>
-        </p:txBody>
-      </p:sp>
-      <p:sp>
-        <p:nvSpPr>
-          <p:cNvPr id="9" name="TextBox 8"/>
-          <p:cNvSpPr txBox="1"/>
-          <p:nvPr/>
-        </p:nvSpPr>
-        <p:spPr>
-          <a:xfrm>
-            <a:off x="822960" y="4754880"/>
-            <a:ext cx="10515600" cy="566928"/>
-          </a:xfrm>
-          <a:prstGeom prst="rect">
-            <a:avLst/>
-          </a:prstGeom>
-          <a:noFill/>
-        </p:spPr>
-        <p:txBody>
-          <a:bodyPr wrap="square">
-            <a:spAutoFit/>
-          </a:bodyPr>
-          <a:lstStyle/>
-          <a:p>
-            <a:pPr>
-              <a:defRPr sz="1800" b="0">
-                <a:solidFill>
-                  <a:srgbClr val="12372A"/>
-                </a:solidFill>
-                <a:latin typeface="Aptos"/>
-              </a:defRPr>
-            </a:pPr>
-            <a:r>
-              <a:t>• Đánh dấu món chưa đủ hồ sơ là pending, không đưa vào launch menu</a:t>
-            </a:r>
-          </a:p>
-        </p:txBody>
-      </p:sp>
-      <p:sp>
-        <p:nvSpPr>
-          <p:cNvPr id="10" name="TextBox 9"/>
-          <p:cNvSpPr txBox="1"/>
-          <p:nvPr/>
-        </p:nvSpPr>
-        <p:spPr>
-          <a:xfrm>
-            <a:off x="640080" y="6473952"/>
-            <a:ext cx="10881360" cy="201168"/>
-          </a:xfrm>
-          <a:prstGeom prst="rect">
-            <a:avLst/>
-          </a:prstGeom>
-          <a:noFill/>
-        </p:spPr>
-        <p:txBody>
-          <a:bodyPr wrap="square">
-            <a:spAutoFit/>
-          </a:bodyPr>
-          <a:lstStyle/>
-          <a:p>
-            <a:pPr>
-              <a:defRPr sz="900" b="0">
-                <a:solidFill>
-                  <a:srgbClr val="567064"/>
-                </a:solidFill>
-                <a:latin typeface="Aptos"/>
-              </a:defRPr>
-            </a:pPr>
-            <a:r>
-              <a:t>Owner: Klaus · Dependency: tasting + supplier price lists</a:t>
-            </a:r>
-          </a:p>
-        </p:txBody>
-      </p:sp>
-    </p:spTree>
-  </p:cSld>
-  <p:clrMapOvr>
-    <a:masterClrMapping/>
-  </p:clrMapOvr>
-</p:sld>
-</file>
-
-<file path=ppt/slides/slide7.xml><?xml version="1.0" encoding="utf-8"?>
-<p:sld xmlns:a="http://schemas.openxmlformats.org/drawingml/2006/main" xmlns:p="http://schemas.openxmlformats.org/presentationml/2006/main" xmlns:r="http://schemas.openxmlformats.org/officeDocument/2006/relationships">
-  <p:cSld>
-    <p:spTree>
-      <p:nvGrpSpPr>
-        <p:cNvPr id="1" name=""/>
-        <p:cNvGrpSpPr/>
-        <p:nvPr/>
-      </p:nvGrpSpPr>
-      <p:grpSpPr/>
-      <p:sp>
-        <p:nvSpPr>
-          <p:cNvPr id="2" name="Rectangle 1"/>
-          <p:cNvSpPr/>
-          <p:nvPr/>
-        </p:nvSpPr>
-        <p:spPr>
-          <a:xfrm>
-            <a:off x="0" y="0"/>
-            <a:ext cx="12191695" cy="6858000"/>
-          </a:xfrm>
-          <a:prstGeom prst="rect">
+          <a:prstGeom prst="roundRect">
             <a:avLst/>
           </a:prstGeom>
           <a:solidFill>
-            <a:srgbClr val="12372A"/>
+            <a:srgbClr val="1C2541"/>
           </a:solidFill>
-          <a:ln>
-            <a:noFill/>
+          <a:ln w="12700">
+            <a:solidFill>
+              <a:srgbClr val="3A506B"/>
+            </a:solidFill>
           </a:ln>
         </p:spPr>
         <p:style>
@@ -4992,14 +4174,14 @@
       </p:sp>
       <p:sp>
         <p:nvSpPr>
-          <p:cNvPr id="3" name="TextBox 2"/>
+          <p:cNvPr id="9" name="TextBox 8"/>
           <p:cNvSpPr txBox="1"/>
           <p:nvPr/>
         </p:nvSpPr>
         <p:spPr>
           <a:xfrm>
-            <a:off x="640080" y="502920"/>
-            <a:ext cx="10881360" cy="685800"/>
+            <a:off x="960120" y="4297680"/>
+            <a:ext cx="4754880" cy="1828800"/>
           </a:xfrm>
           <a:prstGeom prst="rect">
             <a:avLst/>
@@ -5013,29 +4195,98 @@
           <a:lstStyle/>
           <a:p>
             <a:pPr>
-              <a:defRPr sz="2800" b="1">
+              <a:defRPr sz="1500" b="1">
+                <a:solidFill>
+                  <a:srgbClr val="FFD166"/>
+                </a:solidFill>
+                <a:latin typeface="Segoe UI"/>
+              </a:defRPr>
+            </a:pPr>
+            <a:r>
+              <a:t>3. Thử Mẫu (Tasting) &amp; Chọn Nhà Cung Cấp</a:t>
+            </a:r>
+          </a:p>
+          <a:p>
+            <a:pPr>
+              <a:spcBef>
+                <a:spcPts val="600"/>
+              </a:spcBef>
+              <a:defRPr sz="1150">
                 <a:solidFill>
                   <a:srgbClr val="FFFFFF"/>
                 </a:solidFill>
-                <a:latin typeface="Aptos"/>
+                <a:latin typeface="Segoe UI"/>
               </a:defRPr>
             </a:pPr>
             <a:r>
-              <a:t>Definition of Done · 30/08</a:t>
-            </a:r>
-          </a:p>
-        </p:txBody>
-      </p:sp>
-      <p:sp>
-        <p:nvSpPr>
-          <p:cNvPr id="4" name="TextBox 3"/>
+              <a:t>• Tasting 5 SKU RTD từ Wana Beverage &amp; Interfresh Củ Chi.</a:t>
+            </a:r>
+            <a:br/>
+            <a:r>
+              <a:t>• Yêu cầu bản Tự công bố sản phẩm và chứng nhận ISO/HACCP.</a:t>
+            </a:r>
+            <a:br/>
+            <a:r>
+              <a:t>• Đàm phán hạn mức thanh toán công nợ 15-30 ngày.</a:t>
+            </a:r>
+          </a:p>
+        </p:txBody>
+      </p:sp>
+      <p:sp>
+        <p:nvSpPr>
+          <p:cNvPr id="10" name="Rounded Rectangle 9"/>
+          <p:cNvSpPr/>
+          <p:nvPr/>
+        </p:nvSpPr>
+        <p:spPr>
+          <a:xfrm>
+            <a:off x="6217920" y="4114800"/>
+            <a:ext cx="5212080" cy="2194560"/>
+          </a:xfrm>
+          <a:prstGeom prst="roundRect">
+            <a:avLst/>
+          </a:prstGeom>
+          <a:solidFill>
+            <a:srgbClr val="1C2541"/>
+          </a:solidFill>
+          <a:ln w="12700">
+            <a:solidFill>
+              <a:srgbClr val="3A506B"/>
+            </a:solidFill>
+          </a:ln>
+        </p:spPr>
+        <p:style>
+          <a:lnRef idx="1">
+            <a:schemeClr val="accent1"/>
+          </a:lnRef>
+          <a:fillRef idx="3">
+            <a:schemeClr val="accent1"/>
+          </a:fillRef>
+          <a:effectRef idx="2">
+            <a:schemeClr val="accent1"/>
+          </a:effectRef>
+          <a:fontRef idx="minor">
+            <a:schemeClr val="lt1"/>
+          </a:fontRef>
+        </p:style>
+        <p:txBody>
+          <a:bodyPr rtlCol="0" anchor="ctr"/>
+          <a:lstStyle/>
+          <a:p>
+            <a:pPr algn="ctr"/>
+          </a:p>
+        </p:txBody>
+      </p:sp>
+      <p:sp>
+        <p:nvSpPr>
+          <p:cNvPr id="11" name="TextBox 10"/>
           <p:cNvSpPr txBox="1"/>
           <p:nvPr/>
         </p:nvSpPr>
         <p:spPr>
           <a:xfrm>
-            <a:off x="822960" y="1417320"/>
-            <a:ext cx="10515600" cy="566928"/>
+            <a:off x="6446520" y="4297680"/>
+            <a:ext cx="4754880" cy="1828800"/>
           </a:xfrm>
           <a:prstGeom prst="rect">
             <a:avLst/>
@@ -5049,231 +4300,39 @@
           <a:lstStyle/>
           <a:p>
             <a:pPr>
-              <a:defRPr sz="1800" b="1">
-                <a:solidFill>
-                  <a:srgbClr val="12372A"/>
-                </a:solidFill>
-                <a:latin typeface="Aptos"/>
+              <a:defRPr sz="1500" b="1">
+                <a:solidFill>
+                  <a:srgbClr val="EF476F"/>
+                </a:solidFill>
+                <a:latin typeface="Segoe UI"/>
               </a:defRPr>
             </a:pPr>
             <a:r>
-              <a:t>• □ 8 mặt bằng đã khảo sát và có checklist/ảnh</a:t>
-            </a:r>
-          </a:p>
-        </p:txBody>
-      </p:sp>
-      <p:sp>
-        <p:nvSpPr>
-          <p:cNvPr id="5" name="TextBox 4"/>
-          <p:cNvSpPr txBox="1"/>
-          <p:nvPr/>
-        </p:nvSpPr>
-        <p:spPr>
-          <a:xfrm>
-            <a:off x="822960" y="2084832"/>
-            <a:ext cx="10515600" cy="566928"/>
-          </a:xfrm>
-          <a:prstGeom prst="rect">
-            <a:avLst/>
-          </a:prstGeom>
-          <a:noFill/>
-        </p:spPr>
-        <p:txBody>
-          <a:bodyPr wrap="square">
-            <a:spAutoFit/>
-          </a:bodyPr>
-          <a:lstStyle/>
+              <a:t>4. Menu Engineering &amp; Định Mức COGS</a:t>
+            </a:r>
+          </a:p>
           <a:p>
             <a:pPr>
-              <a:defRPr sz="1800" b="0">
-                <a:solidFill>
-                  <a:srgbClr val="12372A"/>
-                </a:solidFill>
-                <a:latin typeface="Aptos"/>
+              <a:spcBef>
+                <a:spcPts val="600"/>
+              </a:spcBef>
+              <a:defRPr sz="1150">
+                <a:solidFill>
+                  <a:srgbClr val="FFFFFF"/>
+                </a:solidFill>
+                <a:latin typeface="Segoe UI"/>
               </a:defRPr>
             </a:pPr>
             <a:r>
-              <a:t>• □ 3–5 mặt bằng shortlist, không vi phạm flood line</a:t>
-            </a:r>
-          </a:p>
-        </p:txBody>
-      </p:sp>
-      <p:sp>
-        <p:nvSpPr>
-          <p:cNvPr id="6" name="TextBox 5"/>
-          <p:cNvSpPr txBox="1"/>
-          <p:nvPr/>
-        </p:nvSpPr>
-        <p:spPr>
-          <a:xfrm>
-            <a:off x="822960" y="2752344"/>
-            <a:ext cx="10515600" cy="566928"/>
-          </a:xfrm>
-          <a:prstGeom prst="rect">
-            <a:avLst/>
-          </a:prstGeom>
-          <a:noFill/>
-        </p:spPr>
-        <p:txBody>
-          <a:bodyPr wrap="square">
-            <a:spAutoFit/>
-          </a:bodyPr>
-          <a:lstStyle/>
-          <a:p>
-            <a:pPr>
-              <a:defRPr sz="1800" b="0">
-                <a:solidFill>
-                  <a:srgbClr val="12372A"/>
-                </a:solidFill>
-                <a:latin typeface="Aptos"/>
-              </a:defRPr>
-            </a:pPr>
-            <a:r>
-              <a:t>• □ Kết quả tasting ≥5 SKU, có scorecard và hồ sơ nhà cung cấp</a:t>
-            </a:r>
-          </a:p>
-        </p:txBody>
-      </p:sp>
-      <p:sp>
-        <p:nvSpPr>
-          <p:cNvPr id="7" name="TextBox 6"/>
-          <p:cNvSpPr txBox="1"/>
-          <p:nvPr/>
-        </p:nvSpPr>
-        <p:spPr>
-          <a:xfrm>
-            <a:off x="822960" y="3419856"/>
-            <a:ext cx="10515600" cy="566928"/>
-          </a:xfrm>
-          <a:prstGeom prst="rect">
-            <a:avLst/>
-          </a:prstGeom>
-          <a:noFill/>
-        </p:spPr>
-        <p:txBody>
-          <a:bodyPr wrap="square">
-            <a:spAutoFit/>
-          </a:bodyPr>
-          <a:lstStyle/>
-          <a:p>
-            <a:pPr>
-              <a:defRPr sz="1800" b="0">
-                <a:solidFill>
-                  <a:srgbClr val="12372A"/>
-                </a:solidFill>
-                <a:latin typeface="Aptos"/>
-              </a:defRPr>
-            </a:pPr>
-            <a:r>
-              <a:t>• □ Menu v1 + COGS từng món + các lỗ hổng hồ sơ được đánh dấu</a:t>
-            </a:r>
-          </a:p>
-        </p:txBody>
-      </p:sp>
-      <p:sp>
-        <p:nvSpPr>
-          <p:cNvPr id="8" name="TextBox 7"/>
-          <p:cNvSpPr txBox="1"/>
-          <p:nvPr/>
-        </p:nvSpPr>
-        <p:spPr>
-          <a:xfrm>
-            <a:off x="822960" y="4087368"/>
-            <a:ext cx="10515600" cy="566928"/>
-          </a:xfrm>
-          <a:prstGeom prst="rect">
-            <a:avLst/>
-          </a:prstGeom>
-          <a:noFill/>
-        </p:spPr>
-        <p:txBody>
-          <a:bodyPr wrap="square">
-            <a:spAutoFit/>
-          </a:bodyPr>
-          <a:lstStyle/>
-          <a:p>
-            <a:pPr>
-              <a:defRPr sz="1800" b="0">
-                <a:solidFill>
-                  <a:srgbClr val="12372A"/>
-                </a:solidFill>
-                <a:latin typeface="Aptos"/>
-              </a:defRPr>
-            </a:pPr>
-            <a:r>
-              <a:t>• □ ERC, thuế, hóa đơn điện tử: mỗi mục có trạng thái và người phụ trách</a:t>
-            </a:r>
-          </a:p>
-        </p:txBody>
-      </p:sp>
-      <p:sp>
-        <p:nvSpPr>
-          <p:cNvPr id="9" name="TextBox 8"/>
-          <p:cNvSpPr txBox="1"/>
-          <p:nvPr/>
-        </p:nvSpPr>
-        <p:spPr>
-          <a:xfrm>
-            <a:off x="822960" y="4754880"/>
-            <a:ext cx="10515600" cy="566928"/>
-          </a:xfrm>
-          <a:prstGeom prst="rect">
-            <a:avLst/>
-          </a:prstGeom>
-          <a:noFill/>
-        </p:spPr>
-        <p:txBody>
-          <a:bodyPr wrap="square">
-            <a:spAutoFit/>
-          </a:bodyPr>
-          <a:lstStyle/>
-          <a:p>
-            <a:pPr>
-              <a:defRPr sz="1800" b="0">
-                <a:solidFill>
-                  <a:srgbClr val="12372A"/>
-                </a:solidFill>
-                <a:latin typeface="Aptos"/>
-              </a:defRPr>
-            </a:pPr>
-            <a:r>
-              <a:t>• □ Friday report: blockers, quyết định cần Klaus/partners phê duyệt, next actions</a:t>
-            </a:r>
-          </a:p>
-        </p:txBody>
-      </p:sp>
-      <p:sp>
-        <p:nvSpPr>
-          <p:cNvPr id="10" name="TextBox 9"/>
-          <p:cNvSpPr txBox="1"/>
-          <p:nvPr/>
-        </p:nvSpPr>
-        <p:spPr>
-          <a:xfrm>
-            <a:off x="640080" y="6473952"/>
-            <a:ext cx="10881360" cy="201168"/>
-          </a:xfrm>
-          <a:prstGeom prst="rect">
-            <a:avLst/>
-          </a:prstGeom>
-          <a:noFill/>
-        </p:spPr>
-        <p:txBody>
-          <a:bodyPr wrap="square">
-            <a:spAutoFit/>
-          </a:bodyPr>
-          <a:lstStyle/>
-          <a:p>
-            <a:pPr>
-              <a:defRPr sz="900" b="0">
-                <a:solidFill>
-                  <a:srgbClr val="FFFFFF"/>
-                </a:solidFill>
-                <a:latin typeface="Aptos"/>
-              </a:defRPr>
-            </a:pPr>
-            <a:r>
-              <a:t>Friday review · 30/08/2026</a:t>
+              <a:t>• Khóa công thức chuẩn cho 8 món Signature Protein Shake.</a:t>
+            </a:r>
+            <a:br/>
+            <a:r>
+              <a:t>• Thiết lập định mức COGS mục tiêu: 28% – 32% giá bán lẻ.</a:t>
+            </a:r>
+            <a:br/>
+            <a:r>
+              <a:t>• Chốt danh mục thiết bị quầy bar (Máy Espresso, Blender công nghiệp).</a:t>
             </a:r>
           </a:p>
         </p:txBody>

</xml_diff>